<commit_message>
D-74: upgrade presentation deck to Iteration 2, purge speaker-notes companion from git
- A11yAudit_presentation.pptx: new slide 12 (real-page testing findings),
  Limits slide's two stale claims corrected (D-67 hand-scoring, D-36 already
  fixed by D-59), Close renumbered 12->13, footers updated 13-slide total.
  Edited directly at OOXML level (no Node.js/LibreOffice here); no visual
  render possible, verified structurally instead.
- meta/slide_notes_plain.md removed from the working tree; history purged
  via git filter-repo across all branches per author's instruction. Local
  copy kept outside the repo at a11yaudit-agent/slide_notes_plain.md.

Co-Authored-By: Claude Sonnet 5 <noreply@anthropic.com>
</commit_message>
<xml_diff>
--- a/A11yAudit_presentation.pptx
+++ b/A11yAudit_presentation.pptx
@@ -16,6 +16,7 @@
     <p:sldId id="264" r:id="rId10"/>
     <p:sldId id="265" r:id="rId11"/>
     <p:sldId id="266" r:id="rId12"/>
+    <p:sldId id="269" r:id="rId20"/>
     <p:sldId id="267" r:id="rId13"/>
     <p:sldId id="268" r:id="rId14"/>
   </p:sldIdLst>
@@ -2015,7 +2016,7 @@
                 <a:ea typeface="Avenir Next" pitchFamily="34" charset="-122"/>
                 <a:cs typeface="Avenir Next" pitchFamily="34" charset="-120"/>
               </a:rPr>
-              <a:t>01 / 12</a:t>
+              <a:t>01 / 13</a:t>
             </a:r>
             <a:endParaRPr lang="en-US" sz="800" dirty="0"/>
           </a:p>
@@ -2304,7 +2305,7 @@
                 <a:ea typeface="Avenir Next" pitchFamily="34" charset="-122"/>
                 <a:cs typeface="Avenir Next" pitchFamily="34" charset="-120"/>
               </a:rPr>
-              <a:t>10 / 12</a:t>
+              <a:t>10 / 13</a:t>
             </a:r>
             <a:endParaRPr lang="en-US" sz="800" dirty="0"/>
           </a:p>
@@ -3538,7 +3539,7 @@
                 <a:ea typeface="Avenir Next" pitchFamily="34" charset="-122"/>
                 <a:cs typeface="Avenir Next" pitchFamily="34" charset="-120"/>
               </a:rPr>
-              <a:t>11 / 12</a:t>
+              <a:t>11 / 13</a:t>
             </a:r>
             <a:endParaRPr lang="en-US" sz="800" dirty="0"/>
           </a:p>
@@ -3778,7 +3779,7 @@
                 <a:ea typeface="Avenir Next" pitchFamily="34" charset="-122"/>
                 <a:cs typeface="Avenir Next" pitchFamily="34" charset="-120"/>
               </a:rPr>
-              <a:t>Accuracy is unmeasured</a:t>
+              <a:t>Accuracy: one data point, not a validation</a:t>
             </a:r>
             <a:endParaRPr lang="en-US" sz="1250" dirty="0"/>
           </a:p>
@@ -3820,7 +3821,7 @@
                 <a:ea typeface="Avenir Next" pitchFamily="34" charset="-122"/>
                 <a:cs typeface="Avenir Next" pitchFamily="34" charset="-120"/>
               </a:rPr>
-              <a:t>No comparison against expert human auditors was run. The database is structured so a false-positive rate can be derived. That is the next project.</a:t>
+              <a:t>One rater hand-scored two fixtures blind and compared against the AI: 74.5% agreement. One rater, two fixtures — not PEMAT’s own two-rater design, and not a substitute for a false-positive rate from routine use.</a:t>
             </a:r>
             <a:endParaRPr lang="en-US" sz="1050" dirty="0"/>
           </a:p>
@@ -3859,7 +3860,7 @@
                 <a:ea typeface="Avenir Next" pitchFamily="34" charset="-122"/>
                 <a:cs typeface="Avenir Next" pitchFamily="34" charset="-120"/>
               </a:rPr>
-              <a:t>A known defect I chose not to fix</a:t>
+              <a:t>The intake form has no authentication</a:t>
             </a:r>
             <a:endParaRPr lang="en-US" sz="1250" dirty="0"/>
           </a:p>
@@ -3901,7 +3902,7 @@
                 <a:ea typeface="Avenir Next" pitchFamily="34" charset="-122"/>
                 <a:cs typeface="Avenir Next" pitchFamily="34" charset="-120"/>
               </a:rPr>
-              <a:t>Pasted text plus a dead AI means nothing is screened, and the score reads 100. Documented as D-36. Safety never depended on it.</a:t>
+              <a:t>Anyone reaching the form URL can trigger a paid AI call. Not a risk while unpublished; a hard gate before any public exposure.</a:t>
             </a:r>
             <a:endParaRPr lang="en-US" sz="1050" dirty="0"/>
           </a:p>
@@ -4011,7 +4012,7 @@
                 <a:ea typeface="Avenir Next" pitchFamily="34" charset="-122"/>
                 <a:cs typeface="Avenir Next" pitchFamily="34" charset="-120"/>
               </a:rPr>
-              <a:t>12  CLOSE</a:t>
+              <a:t>13  CLOSE</a:t>
             </a:r>
             <a:endParaRPr lang="en-US" sz="900" dirty="0"/>
           </a:p>
@@ -4050,7 +4051,7 @@
                 <a:ea typeface="Avenir Next" pitchFamily="34" charset="-122"/>
                 <a:cs typeface="Avenir Next" pitchFamily="34" charset="-120"/>
               </a:rPr>
-              <a:t>12 / 12</a:t>
+              <a:t>13 / 13</a:t>
             </a:r>
             <a:endParaRPr lang="en-US" sz="800" dirty="0"/>
           </a:p>
@@ -4232,7 +4233,7 @@
                 <a:ea typeface="Avenir Next" pitchFamily="34" charset="-122"/>
                 <a:cs typeface="Avenir Next" pitchFamily="34" charset="-120"/>
               </a:rPr>
-              <a:t>readme.md  ·  decision_log.md, 41 entries  ·  demo_output/  ·  screenshots/</a:t>
+              <a:t>readme.md  ·  decision_log.md, 73 entries  ·  demo_output/  ·  screenshots/</a:t>
             </a:r>
             <a:endParaRPr lang="en-US" sz="950" dirty="0"/>
           </a:p>
@@ -5082,6 +5083,1240 @@
 </p:sld>
 </file>
 
+<file path=ppt/slides/slide14.xml><?xml version="1.0" encoding="utf-8"?>
+<p:sld xmlns:a="http://schemas.openxmlformats.org/drawingml/2006/main" xmlns:r="http://schemas.openxmlformats.org/officeDocument/2006/relationships" xmlns:p="http://schemas.openxmlformats.org/presentationml/2006/main">
+  <p:cSld name="Slide 10">
+    <p:bg>
+      <p:bgPr>
+        <a:solidFill>
+          <a:srgbClr val="FFFFFF"/>
+        </a:solidFill>
+      </p:bgPr>
+    </p:bg>
+    <p:spTree>
+      <p:nvGrpSpPr>
+        <p:cNvPr id="1" name=""/>
+        <p:cNvGrpSpPr/>
+        <p:nvPr/>
+      </p:nvGrpSpPr>
+      <p:grpSpPr>
+        <a:xfrm>
+          <a:off x="0" y="0"/>
+          <a:ext cx="0" cy="0"/>
+          <a:chOff x="0" y="0"/>
+          <a:chExt cx="0" cy="0"/>
+        </a:xfrm>
+      </p:grpSpPr>
+      <p:sp>
+        <p:nvSpPr>
+          <p:cNvPr id="2" name="Text 0"/>
+          <p:cNvSpPr/>
+          <p:nvPr/>
+        </p:nvSpPr>
+        <p:spPr>
+          <a:xfrm>
+            <a:off x="566928" y="274320"/>
+            <a:ext cx="8010144" cy="219456"/>
+          </a:xfrm>
+          <a:prstGeom prst="rect">
+            <a:avLst/>
+          </a:prstGeom>
+          <a:noFill/>
+          <a:ln/>
+        </p:spPr>
+        <p:txBody>
+          <a:bodyPr wrap="square" lIns="0" tIns="0" rIns="0" bIns="0" rtlCol="0" anchor="ctr"/>
+          <a:lstStyle/>
+          <a:p>
+            <a:pPr indent="0" marL="0">
+              <a:buNone/>
+            </a:pPr>
+            <a:r>
+              <a:rPr lang="en-US" sz="900" b="1" spc="240" kern="0" dirty="0">
+                <a:solidFill>
+                  <a:srgbClr val="767676"/>
+                </a:solidFill>
+                <a:latin typeface="Avenir Next" pitchFamily="34" charset="0"/>
+                <a:ea typeface="Avenir Next" pitchFamily="34" charset="-122"/>
+                <a:cs typeface="Avenir Next" pitchFamily="34" charset="-120"/>
+              </a:rPr>
+              <a:t>12  ITERATION 2: TESTED AGAINST REAL PAGES</a:t>
+            </a:r>
+            <a:endParaRPr lang="en-US" sz="900" dirty="0"/>
+          </a:p>
+        </p:txBody>
+      </p:sp>
+      <p:sp>
+        <p:nvSpPr>
+          <p:cNvPr id="3" name="Text 1"/>
+          <p:cNvSpPr/>
+          <p:nvPr/>
+        </p:nvSpPr>
+        <p:spPr>
+          <a:xfrm>
+            <a:off x="7479792" y="4668012"/>
+            <a:ext cx="1097280" cy="219456"/>
+          </a:xfrm>
+          <a:prstGeom prst="rect">
+            <a:avLst/>
+          </a:prstGeom>
+          <a:noFill/>
+          <a:ln/>
+        </p:spPr>
+        <p:txBody>
+          <a:bodyPr wrap="square" lIns="0" tIns="0" rIns="0" bIns="0" rtlCol="0" anchor="ctr"/>
+          <a:lstStyle/>
+          <a:p>
+            <a:pPr algn="r" indent="0" marL="0">
+              <a:buNone/>
+            </a:pPr>
+            <a:r>
+              <a:rPr lang="en-US" sz="800" spc="120" kern="0" dirty="0">
+                <a:solidFill>
+                  <a:srgbClr val="767676"/>
+                </a:solidFill>
+                <a:latin typeface="Avenir Next" pitchFamily="34" charset="0"/>
+                <a:ea typeface="Avenir Next" pitchFamily="34" charset="-122"/>
+                <a:cs typeface="Avenir Next" pitchFamily="34" charset="-120"/>
+              </a:rPr>
+              <a:t>12 / 13</a:t>
+            </a:r>
+            <a:endParaRPr lang="en-US" sz="800" dirty="0"/>
+          </a:p>
+        </p:txBody>
+      </p:sp>
+      <p:sp>
+        <p:nvSpPr>
+          <p:cNvPr id="4" name="Text 2"/>
+          <p:cNvSpPr/>
+          <p:nvPr/>
+        </p:nvSpPr>
+        <p:spPr>
+          <a:xfrm>
+            <a:off x="566928" y="731520"/>
+            <a:ext cx="7863840" cy="914400"/>
+          </a:xfrm>
+          <a:prstGeom prst="rect">
+            <a:avLst/>
+          </a:prstGeom>
+          <a:noFill/>
+          <a:ln/>
+        </p:spPr>
+        <p:txBody>
+          <a:bodyPr wrap="square" lIns="0" tIns="0" rIns="0" bIns="0" rtlCol="0" anchor="ctr"/>
+          <a:lstStyle/>
+          <a:p>
+            <a:pPr indent="0" marL="0">
+              <a:lnSpc>
+                <a:spcPts val="3300"/>
+              </a:lnSpc>
+              <a:buNone/>
+            </a:pPr>
+            <a:r>
+              <a:rPr lang="en-US" sz="2500" b="1" spc="-50" kern="0" dirty="0">
+                <a:solidFill>
+                  <a:srgbClr val="111111"/>
+                </a:solidFill>
+                <a:latin typeface="Avenir Next" pitchFamily="34" charset="0"/>
+                <a:ea typeface="Avenir Next" pitchFamily="34" charset="-122"/>
+                <a:cs typeface="Avenir Next" pitchFamily="34" charset="-120"/>
+              </a:rPr>
+              <a:t>Two fixtures became</a:t>
+            </a:r>
+            <a:endParaRPr lang="en-US" sz="2500" dirty="0"/>
+          </a:p>
+          <a:p>
+            <a:pPr indent="0" marL="0">
+              <a:lnSpc>
+                <a:spcPts val="3300"/>
+              </a:lnSpc>
+              <a:buNone/>
+            </a:pPr>
+            <a:r>
+              <a:rPr lang="en-US" sz="2500" b="1" spc="-50" kern="0" dirty="0">
+                <a:solidFill>
+                  <a:srgbClr val="111111"/>
+                </a:solidFill>
+                <a:latin typeface="Avenir Next" pitchFamily="34" charset="0"/>
+                <a:ea typeface="Avenir Next" pitchFamily="34" charset="-122"/>
+                <a:cs typeface="Avenir Next" pitchFamily="34" charset="-120"/>
+              </a:rPr>
+              <a:t>twenty-four real pages.</a:t>
+            </a:r>
+            <a:endParaRPr lang="en-US" sz="2500" dirty="0"/>
+          </a:p>
+        </p:txBody>
+      </p:sp>
+      <p:sp>
+        <p:nvSpPr>
+          <p:cNvPr id="5" name="Text 3"/>
+          <p:cNvSpPr/>
+          <p:nvPr/>
+        </p:nvSpPr>
+        <p:spPr>
+          <a:xfrm>
+            <a:off x="566928" y="1700784"/>
+            <a:ext cx="7315200" cy="256032"/>
+          </a:xfrm>
+          <a:prstGeom prst="rect">
+            <a:avLst/>
+          </a:prstGeom>
+          <a:noFill/>
+          <a:ln/>
+        </p:spPr>
+        <p:txBody>
+          <a:bodyPr wrap="square" lIns="0" tIns="0" rIns="0" bIns="0" rtlCol="0" anchor="ctr"/>
+          <a:lstStyle/>
+          <a:p>
+            <a:pPr indent="0" marL="0">
+              <a:buNone/>
+            </a:pPr>
+            <a:r>
+              <a:rPr lang="en-US" sz="1150" b="1" dirty="0">
+                <a:solidFill>
+                  <a:srgbClr val="C6381A"/>
+                </a:solidFill>
+                <a:latin typeface="Avenir Next" pitchFamily="34" charset="0"/>
+                <a:ea typeface="Avenir Next" pitchFamily="34" charset="-122"/>
+                <a:cs typeface="Avenir Next" pitchFamily="34" charset="-120"/>
+              </a:rPr>
+              <a:t>Rebuilt in Claude Code. Every defect below was found on markup nobody wrote for this tool, not on a hand-built fixture.</a:t>
+            </a:r>
+            <a:endParaRPr lang="en-US" sz="1150" dirty="0"/>
+          </a:p>
+        </p:txBody>
+      </p:sp>
+      <p:sp>
+        <p:nvSpPr>
+          <p:cNvPr id="6" name="Text 4"/>
+          <p:cNvSpPr/>
+          <p:nvPr/>
+        </p:nvSpPr>
+        <p:spPr>
+          <a:xfrm>
+            <a:off x="566928" y="2084832"/>
+            <a:ext cx="365760" cy="256032"/>
+          </a:xfrm>
+          <a:prstGeom prst="rect">
+            <a:avLst/>
+          </a:prstGeom>
+          <a:noFill/>
+          <a:ln/>
+        </p:spPr>
+        <p:txBody>
+          <a:bodyPr wrap="square" lIns="0" tIns="0" rIns="0" bIns="0" rtlCol="0" anchor="ctr"/>
+          <a:lstStyle/>
+          <a:p>
+            <a:pPr indent="0" marL="0">
+              <a:buNone/>
+            </a:pPr>
+            <a:r>
+              <a:rPr lang="en-US" sz="1050" b="1" dirty="0">
+                <a:solidFill>
+                  <a:srgbClr val="BFBFBF"/>
+                </a:solidFill>
+                <a:latin typeface="Avenir Next" pitchFamily="34" charset="0"/>
+                <a:ea typeface="Avenir Next" pitchFamily="34" charset="-122"/>
+                <a:cs typeface="Avenir Next" pitchFamily="34" charset="-120"/>
+              </a:rPr>
+              <a:t>01</a:t>
+            </a:r>
+            <a:endParaRPr lang="en-US" sz="1050" dirty="0"/>
+          </a:p>
+        </p:txBody>
+      </p:sp>
+      <p:sp>
+        <p:nvSpPr>
+          <p:cNvPr id="7" name="Text 5"/>
+          <p:cNvSpPr/>
+          <p:nvPr/>
+        </p:nvSpPr>
+        <p:spPr>
+          <a:xfrm>
+            <a:off x="950976" y="2084832"/>
+            <a:ext cx="3520440" cy="256032"/>
+          </a:xfrm>
+          <a:prstGeom prst="rect">
+            <a:avLst/>
+          </a:prstGeom>
+          <a:noFill/>
+          <a:ln/>
+        </p:spPr>
+        <p:txBody>
+          <a:bodyPr wrap="square" lIns="0" tIns="0" rIns="0" bIns="0" rtlCol="0" anchor="ctr"/>
+          <a:lstStyle/>
+          <a:p>
+            <a:pPr indent="0" marL="0">
+              <a:buNone/>
+            </a:pPr>
+            <a:r>
+              <a:rPr lang="en-US" sz="1100" b="1" dirty="0">
+                <a:solidFill>
+                  <a:srgbClr val="111111"/>
+                </a:solidFill>
+                <a:latin typeface="Avenir Next" pitchFamily="34" charset="0"/>
+                <a:ea typeface="Avenir Next" pitchFamily="34" charset="-122"/>
+                <a:cs typeface="Avenir Next" pitchFamily="34" charset="-120"/>
+              </a:rPr>
+              <a:t>A real page broke content extraction</a:t>
+            </a:r>
+            <a:endParaRPr lang="en-US" sz="1100" dirty="0"/>
+          </a:p>
+        </p:txBody>
+      </p:sp>
+      <p:sp>
+        <p:nvSpPr>
+          <p:cNvPr id="8" name="Text 6"/>
+          <p:cNvSpPr/>
+          <p:nvPr/>
+        </p:nvSpPr>
+        <p:spPr>
+          <a:xfrm>
+            <a:off x="950976" y="2340864"/>
+            <a:ext cx="3520440" cy="384048"/>
+          </a:xfrm>
+          <a:prstGeom prst="rect">
+            <a:avLst/>
+          </a:prstGeom>
+          <a:noFill/>
+          <a:ln/>
+        </p:spPr>
+        <p:txBody>
+          <a:bodyPr wrap="square" lIns="0" tIns="0" rIns="0" bIns="0" rtlCol="0" anchor="t"/>
+          <a:lstStyle/>
+          <a:p>
+            <a:pPr indent="0" marL="0">
+              <a:lnSpc>
+                <a:spcPts val="1200"/>
+              </a:lnSpc>
+              <a:buNone/>
+            </a:pPr>
+            <a:r>
+              <a:rPr lang="en-US" sz="900" dirty="0">
+                <a:solidFill>
+                  <a:srgbClr val="767676"/>
+                </a:solidFill>
+                <a:latin typeface="Avenir Next" pitchFamily="34" charset="0"/>
+                <a:ea typeface="Avenir Next" pitchFamily="34" charset="-122"/>
+                <a:cs typeface="Avenir Next" pitchFamily="34" charset="-120"/>
+              </a:rPr>
+              <a:t>The first live page submitted had its navigation and breadcrumbs read as article content — invisible on every fixture, since none had surrounding page chrome.</a:t>
+            </a:r>
+            <a:endParaRPr lang="en-US" sz="900" dirty="0"/>
+          </a:p>
+        </p:txBody>
+      </p:sp>
+      <p:sp>
+        <p:nvSpPr>
+          <p:cNvPr id="9" name="Text 7"/>
+          <p:cNvSpPr/>
+          <p:nvPr/>
+        </p:nvSpPr>
+        <p:spPr>
+          <a:xfrm>
+            <a:off x="566928" y="2798064"/>
+            <a:ext cx="365760" cy="256032"/>
+          </a:xfrm>
+          <a:prstGeom prst="rect">
+            <a:avLst/>
+          </a:prstGeom>
+          <a:noFill/>
+          <a:ln/>
+        </p:spPr>
+        <p:txBody>
+          <a:bodyPr wrap="square" lIns="0" tIns="0" rIns="0" bIns="0" rtlCol="0" anchor="ctr"/>
+          <a:lstStyle/>
+          <a:p>
+            <a:pPr indent="0" marL="0">
+              <a:buNone/>
+            </a:pPr>
+            <a:r>
+              <a:rPr lang="en-US" sz="1050" b="1" dirty="0">
+                <a:solidFill>
+                  <a:srgbClr val="BFBFBF"/>
+                </a:solidFill>
+                <a:latin typeface="Avenir Next" pitchFamily="34" charset="0"/>
+                <a:ea typeface="Avenir Next" pitchFamily="34" charset="-122"/>
+                <a:cs typeface="Avenir Next" pitchFamily="34" charset="-120"/>
+              </a:rPr>
+              <a:t>02</a:t>
+            </a:r>
+            <a:endParaRPr lang="en-US" sz="1050" dirty="0"/>
+          </a:p>
+        </p:txBody>
+      </p:sp>
+      <p:sp>
+        <p:nvSpPr>
+          <p:cNvPr id="10" name="Text 8"/>
+          <p:cNvSpPr/>
+          <p:nvPr/>
+        </p:nvSpPr>
+        <p:spPr>
+          <a:xfrm>
+            <a:off x="950976" y="2798064"/>
+            <a:ext cx="3520440" cy="256032"/>
+          </a:xfrm>
+          <a:prstGeom prst="rect">
+            <a:avLst/>
+          </a:prstGeom>
+          <a:noFill/>
+          <a:ln/>
+        </p:spPr>
+        <p:txBody>
+          <a:bodyPr wrap="square" lIns="0" tIns="0" rIns="0" bIns="0" rtlCol="0" anchor="ctr"/>
+          <a:lstStyle/>
+          <a:p>
+            <a:pPr indent="0" marL="0">
+              <a:buNone/>
+            </a:pPr>
+            <a:r>
+              <a:rPr lang="en-US" sz="1100" b="1" dirty="0">
+                <a:solidFill>
+                  <a:srgbClr val="111111"/>
+                </a:solidFill>
+                <a:latin typeface="Avenir Next" pitchFamily="34" charset="0"/>
+                <a:ea typeface="Avenir Next" pitchFamily="34" charset="-122"/>
+                <a:cs typeface="Avenir Next" pitchFamily="34" charset="-120"/>
+              </a:rPr>
+              <a:t>The fix itself had a gap</a:t>
+            </a:r>
+            <a:endParaRPr lang="en-US" sz="1100" dirty="0"/>
+          </a:p>
+        </p:txBody>
+      </p:sp>
+      <p:sp>
+        <p:nvSpPr>
+          <p:cNvPr id="11" name="Text 9"/>
+          <p:cNvSpPr/>
+          <p:nvPr/>
+        </p:nvSpPr>
+        <p:spPr>
+          <a:xfrm>
+            <a:off x="950976" y="3054096"/>
+            <a:ext cx="3520440" cy="384048"/>
+          </a:xfrm>
+          <a:prstGeom prst="rect">
+            <a:avLst/>
+          </a:prstGeom>
+          <a:noFill/>
+          <a:ln/>
+        </p:spPr>
+        <p:txBody>
+          <a:bodyPr wrap="square" lIns="0" tIns="0" rIns="0" bIns="0" rtlCol="0" anchor="t"/>
+          <a:lstStyle/>
+          <a:p>
+            <a:pPr indent="0" marL="0">
+              <a:lnSpc>
+                <a:spcPts val="1200"/>
+              </a:lnSpc>
+              <a:buNone/>
+            </a:pPr>
+            <a:r>
+              <a:rPr lang="en-US" sz="900" dirty="0">
+                <a:solidFill>
+                  <a:srgbClr val="767676"/>
+                </a:solidFill>
+                <a:latin typeface="Avenir Next" pitchFamily="34" charset="0"/>
+                <a:ea typeface="Avenir Next" pitchFamily="34" charset="-122"/>
+                <a:cs typeface="Avenir Next" pitchFamily="34" charset="-120"/>
+              </a:rPr>
+              <a:t>Nested navigation inside &lt;main&gt; still leaked through. Found by a synthetic test built to check the fix, not by luck.</a:t>
+            </a:r>
+            <a:endParaRPr lang="en-US" sz="900" dirty="0"/>
+          </a:p>
+        </p:txBody>
+      </p:sp>
+      <p:sp>
+        <p:nvSpPr>
+          <p:cNvPr id="12" name="Text 10"/>
+          <p:cNvSpPr/>
+          <p:nvPr/>
+        </p:nvSpPr>
+        <p:spPr>
+          <a:xfrm>
+            <a:off x="566928" y="3511296"/>
+            <a:ext cx="365760" cy="256032"/>
+          </a:xfrm>
+          <a:prstGeom prst="rect">
+            <a:avLst/>
+          </a:prstGeom>
+          <a:noFill/>
+          <a:ln/>
+        </p:spPr>
+        <p:txBody>
+          <a:bodyPr wrap="square" lIns="0" tIns="0" rIns="0" bIns="0" rtlCol="0" anchor="ctr"/>
+          <a:lstStyle/>
+          <a:p>
+            <a:pPr indent="0" marL="0">
+              <a:buNone/>
+            </a:pPr>
+            <a:r>
+              <a:rPr lang="en-US" sz="1050" b="1" dirty="0">
+                <a:solidFill>
+                  <a:srgbClr val="BFBFBF"/>
+                </a:solidFill>
+                <a:latin typeface="Avenir Next" pitchFamily="34" charset="0"/>
+                <a:ea typeface="Avenir Next" pitchFamily="34" charset="-122"/>
+                <a:cs typeface="Avenir Next" pitchFamily="34" charset="-120"/>
+              </a:rPr>
+              <a:t>03</a:t>
+            </a:r>
+            <a:endParaRPr lang="en-US" sz="1050" dirty="0"/>
+          </a:p>
+        </p:txBody>
+      </p:sp>
+      <p:sp>
+        <p:nvSpPr>
+          <p:cNvPr id="13" name="Text 11"/>
+          <p:cNvSpPr/>
+          <p:nvPr/>
+        </p:nvSpPr>
+        <p:spPr>
+          <a:xfrm>
+            <a:off x="950976" y="3511296"/>
+            <a:ext cx="3520440" cy="256032"/>
+          </a:xfrm>
+          <a:prstGeom prst="rect">
+            <a:avLst/>
+          </a:prstGeom>
+          <a:noFill/>
+          <a:ln/>
+        </p:spPr>
+        <p:txBody>
+          <a:bodyPr wrap="square" lIns="0" tIns="0" rIns="0" bIns="0" rtlCol="0" anchor="ctr"/>
+          <a:lstStyle/>
+          <a:p>
+            <a:pPr indent="0" marL="0">
+              <a:buNone/>
+            </a:pPr>
+            <a:r>
+              <a:rPr lang="en-US" sz="1100" b="1" dirty="0">
+                <a:solidFill>
+                  <a:srgbClr val="111111"/>
+                </a:solidFill>
+                <a:latin typeface="Avenir Next" pitchFamily="34" charset="0"/>
+                <a:ea typeface="Avenir Next" pitchFamily="34" charset="-122"/>
+                <a:cs typeface="Avenir Next" pitchFamily="34" charset="-120"/>
+              </a:rPr>
+              <a:t>A documentation comment broke the database</a:t>
+            </a:r>
+            <a:endParaRPr lang="en-US" sz="1100" dirty="0"/>
+          </a:p>
+        </p:txBody>
+      </p:sp>
+      <p:sp>
+        <p:nvSpPr>
+          <p:cNvPr id="14" name="Text 12"/>
+          <p:cNvSpPr/>
+          <p:nvPr/>
+        </p:nvSpPr>
+        <p:spPr>
+          <a:xfrm>
+            <a:off x="950976" y="3767328"/>
+            <a:ext cx="3520440" cy="384048"/>
+          </a:xfrm>
+          <a:prstGeom prst="rect">
+            <a:avLst/>
+          </a:prstGeom>
+          <a:noFill/>
+          <a:ln/>
+        </p:spPr>
+        <p:txBody>
+          <a:bodyPr wrap="square" lIns="0" tIns="0" rIns="0" bIns="0" rtlCol="0" anchor="t"/>
+          <a:lstStyle/>
+          <a:p>
+            <a:pPr indent="0" marL="0">
+              <a:lnSpc>
+                <a:spcPts val="1200"/>
+              </a:lnSpc>
+              <a:buNone/>
+            </a:pPr>
+            <a:r>
+              <a:rPr lang="en-US" sz="900" dirty="0">
+                <a:solidFill>
+                  <a:srgbClr val="767676"/>
+                </a:solidFill>
+                <a:latin typeface="Avenir Next" pitchFamily="34" charset="0"/>
+                <a:ea typeface="Avenir Next" pitchFamily="34" charset="-122"/>
+                <a:cs typeface="Avenir Next" pitchFamily="34" charset="-120"/>
+              </a:rPr>
+              <a:t>A live n8n expression sat inside a SQL comment. An AI finding with an embedded newline turned the comment into executable SQL and crashed the write.</a:t>
+            </a:r>
+            <a:endParaRPr lang="en-US" sz="900" dirty="0"/>
+          </a:p>
+        </p:txBody>
+      </p:sp>
+      <p:sp>
+        <p:nvSpPr>
+          <p:cNvPr id="15" name="Shape 13"/>
+          <p:cNvSpPr/>
+          <p:nvPr/>
+        </p:nvSpPr>
+        <p:spPr>
+          <a:xfrm>
+            <a:off x="4828032" y="2011680"/>
+            <a:ext cx="3749040" cy="2194560"/>
+          </a:xfrm>
+          <a:prstGeom prst="rect">
+            <a:avLst/>
+          </a:prstGeom>
+          <a:solidFill>
+            <a:srgbClr val="F4F4F4"/>
+          </a:solidFill>
+          <a:ln w="12700">
+            <a:solidFill>
+              <a:srgbClr val="F4F4F4"/>
+            </a:solidFill>
+            <a:prstDash val="solid"/>
+          </a:ln>
+        </p:spPr>
+      </p:sp>
+      <p:sp>
+        <p:nvSpPr>
+          <p:cNvPr id="16" name="Text 14"/>
+          <p:cNvSpPr/>
+          <p:nvPr/>
+        </p:nvSpPr>
+        <p:spPr>
+          <a:xfrm>
+            <a:off x="5029200" y="2157984"/>
+            <a:ext cx="3383280" cy="201168"/>
+          </a:xfrm>
+          <a:prstGeom prst="rect">
+            <a:avLst/>
+          </a:prstGeom>
+          <a:noFill/>
+          <a:ln/>
+        </p:spPr>
+        <p:txBody>
+          <a:bodyPr wrap="square" lIns="0" tIns="0" rIns="0" bIns="0" rtlCol="0" anchor="ctr"/>
+          <a:lstStyle/>
+          <a:p>
+            <a:pPr indent="0" marL="0">
+              <a:buNone/>
+            </a:pPr>
+            <a:r>
+              <a:rPr lang="en-US" sz="800" b="1" spc="100" kern="0" dirty="0">
+                <a:solidFill>
+                  <a:srgbClr val="C6381A"/>
+                </a:solidFill>
+                <a:latin typeface="Avenir Next" pitchFamily="34" charset="0"/>
+                <a:ea typeface="Avenir Next" pitchFamily="34" charset="-122"/>
+                <a:cs typeface="Avenir Next" pitchFamily="34" charset="-120"/>
+              </a:rPr>
+              <a:t>DECISION LOG: 73 ENTRIES</a:t>
+            </a:r>
+            <a:endParaRPr lang="en-US" sz="800" dirty="0"/>
+          </a:p>
+        </p:txBody>
+      </p:sp>
+      <p:sp>
+        <p:nvSpPr>
+          <p:cNvPr id="17" name="Text 15"/>
+          <p:cNvSpPr/>
+          <p:nvPr/>
+        </p:nvSpPr>
+        <p:spPr>
+          <a:xfrm>
+            <a:off x="5029200" y="2395728"/>
+            <a:ext cx="3383280" cy="1664208"/>
+          </a:xfrm>
+          <a:prstGeom prst="rect">
+            <a:avLst/>
+          </a:prstGeom>
+          <a:noFill/>
+          <a:ln/>
+        </p:spPr>
+        <p:txBody>
+          <a:bodyPr wrap="square" lIns="0" tIns="0" rIns="0" bIns="0" rtlCol="0" anchor="t"/>
+          <a:lstStyle/>
+          <a:p>
+            <a:pPr indent="0" marL="0">
+              <a:lnSpc>
+                <a:spcPts val="940"/>
+              </a:lnSpc>
+              <a:buNone/>
+            </a:pPr>
+            <a:r>
+              <a:rPr lang="en-US" sz="720" b="1" dirty="0">
+                <a:solidFill>
+                  <a:srgbClr val="9A9A9A"/>
+                </a:solidFill>
+                <a:latin typeface="Avenir Next" pitchFamily="34" charset="0"/>
+                <a:ea typeface="Avenir Next" pitchFamily="34" charset="-122"/>
+                <a:cs typeface="Avenir Next" pitchFamily="34" charset="-120"/>
+              </a:rPr>
+              <a:t>D-62  </a:t>
+            </a:r>
+            <a:pPr indent="0" marL="0">
+              <a:lnSpc>
+                <a:spcPts val="940"/>
+              </a:lnSpc>
+              <a:buNone/>
+            </a:pPr>
+            <a:r>
+              <a:rPr lang="en-US" sz="720" dirty="0">
+                <a:solidFill>
+                  <a:srgbClr val="767676"/>
+                </a:solidFill>
+                <a:latin typeface="Avenir Next" pitchFamily="34" charset="0"/>
+                <a:ea typeface="Avenir Next" pitchFamily="34" charset="-122"/>
+                <a:cs typeface="Avenir Next" pitchFamily="34" charset="-120"/>
+              </a:rPr>
+              <a:t>Prompt-injection mitigation added</a:t>
+            </a:r>
+            <a:endParaRPr lang="en-US" sz="720" dirty="0"/>
+          </a:p>
+          <a:p>
+            <a:pPr indent="0" marL="0">
+              <a:lnSpc>
+                <a:spcPts val="940"/>
+              </a:lnSpc>
+              <a:buNone/>
+            </a:pPr>
+            <a:r>
+              <a:rPr lang="en-US" sz="720" b="1" dirty="0">
+                <a:solidFill>
+                  <a:srgbClr val="9A9A9A"/>
+                </a:solidFill>
+                <a:latin typeface="Avenir Next" pitchFamily="34" charset="0"/>
+                <a:ea typeface="Avenir Next" pitchFamily="34" charset="-122"/>
+                <a:cs typeface="Avenir Next" pitchFamily="34" charset="-120"/>
+              </a:rPr>
+              <a:t>D-63  </a:t>
+            </a:r>
+            <a:pPr indent="0" marL="0">
+              <a:lnSpc>
+                <a:spcPts val="940"/>
+              </a:lnSpc>
+              <a:buNone/>
+            </a:pPr>
+            <a:r>
+              <a:rPr lang="en-US" sz="720" dirty="0">
+                <a:solidFill>
+                  <a:srgbClr val="767676"/>
+                </a:solidFill>
+                <a:latin typeface="Avenir Next" pitchFamily="34" charset="0"/>
+                <a:ea typeface="Avenir Next" pitchFamily="34" charset="-122"/>
+                <a:cs typeface="Avenir Next" pitchFamily="34" charset="-120"/>
+              </a:rPr>
+              <a:t>audit_runs: one row per execution</a:t>
+            </a:r>
+            <a:endParaRPr lang="en-US" sz="720" dirty="0"/>
+          </a:p>
+          <a:p>
+            <a:pPr indent="0" marL="0">
+              <a:lnSpc>
+                <a:spcPts val="940"/>
+              </a:lnSpc>
+              <a:buNone/>
+            </a:pPr>
+            <a:r>
+              <a:rPr lang="en-US" sz="720" b="1" dirty="0">
+                <a:solidFill>
+                  <a:srgbClr val="C6381A"/>
+                </a:solidFill>
+                <a:latin typeface="Avenir Next" pitchFamily="34" charset="0"/>
+                <a:ea typeface="Avenir Next" pitchFamily="34" charset="-122"/>
+                <a:cs typeface="Avenir Next" pitchFamily="34" charset="-120"/>
+              </a:rPr>
+              <a:t>D-64  </a:t>
+            </a:r>
+            <a:pPr indent="0" marL="0">
+              <a:lnSpc>
+                <a:spcPts val="940"/>
+              </a:lnSpc>
+              <a:buNone/>
+            </a:pPr>
+            <a:r>
+              <a:rPr lang="en-US" sz="720" dirty="0">
+                <a:solidFill>
+                  <a:srgbClr val="111111"/>
+                </a:solidFill>
+                <a:latin typeface="Avenir Next" pitchFamily="34" charset="0"/>
+                <a:ea typeface="Avenir Next" pitchFamily="34" charset="-122"/>
+                <a:cs typeface="Avenir Next" pitchFamily="34" charset="-120"/>
+              </a:rPr>
+              <a:t>instrument_items write path finally built</a:t>
+            </a:r>
+            <a:endParaRPr lang="en-US" sz="720" dirty="0"/>
+          </a:p>
+          <a:p>
+            <a:pPr indent="0" marL="0">
+              <a:lnSpc>
+                <a:spcPts val="940"/>
+              </a:lnSpc>
+              <a:buNone/>
+            </a:pPr>
+            <a:r>
+              <a:rPr lang="en-US" sz="720" b="1" dirty="0">
+                <a:solidFill>
+                  <a:srgbClr val="C6381A"/>
+                </a:solidFill>
+                <a:latin typeface="Avenir Next" pitchFamily="34" charset="0"/>
+                <a:ea typeface="Avenir Next" pitchFamily="34" charset="-122"/>
+                <a:cs typeface="Avenir Next" pitchFamily="34" charset="-120"/>
+              </a:rPr>
+              <a:t>D-66  </a:t>
+            </a:r>
+            <a:pPr indent="0" marL="0">
+              <a:lnSpc>
+                <a:spcPts val="940"/>
+              </a:lnSpc>
+              <a:buNone/>
+            </a:pPr>
+            <a:r>
+              <a:rPr lang="en-US" sz="720" dirty="0">
+                <a:solidFill>
+                  <a:srgbClr val="111111"/>
+                </a:solidFill>
+                <a:latin typeface="Avenir Next" pitchFamily="34" charset="0"/>
+                <a:ea typeface="Avenir Next" pitchFamily="34" charset="-122"/>
+                <a:cs typeface="Avenir Next" pitchFamily="34" charset="-120"/>
+              </a:rPr>
+              <a:t>Least-privilege Postgres role switched on</a:t>
+            </a:r>
+            <a:endParaRPr lang="en-US" sz="720" dirty="0"/>
+          </a:p>
+          <a:p>
+            <a:pPr indent="0" marL="0">
+              <a:lnSpc>
+                <a:spcPts val="940"/>
+              </a:lnSpc>
+              <a:buNone/>
+            </a:pPr>
+            <a:r>
+              <a:rPr lang="en-US" sz="720" b="1" dirty="0">
+                <a:solidFill>
+                  <a:srgbClr val="9A9A9A"/>
+                </a:solidFill>
+                <a:latin typeface="Avenir Next" pitchFamily="34" charset="0"/>
+                <a:ea typeface="Avenir Next" pitchFamily="34" charset="-122"/>
+                <a:cs typeface="Avenir Next" pitchFamily="34" charset="-120"/>
+              </a:rPr>
+              <a:t>D-67  </a:t>
+            </a:r>
+            <a:pPr indent="0" marL="0">
+              <a:lnSpc>
+                <a:spcPts val="940"/>
+              </a:lnSpc>
+              <a:buNone/>
+            </a:pPr>
+            <a:r>
+              <a:rPr lang="en-US" sz="720" dirty="0">
+                <a:solidFill>
+                  <a:srgbClr val="767676"/>
+                </a:solidFill>
+                <a:latin typeface="Avenir Next" pitchFamily="34" charset="0"/>
+                <a:ea typeface="Avenir Next" pitchFamily="34" charset="-122"/>
+                <a:cs typeface="Avenir Next" pitchFamily="34" charset="-120"/>
+              </a:rPr>
+              <a:t>Hand-scoring: 74.5% AI/human agreement</a:t>
+            </a:r>
+            <a:endParaRPr lang="en-US" sz="720" dirty="0"/>
+          </a:p>
+          <a:p>
+            <a:pPr indent="0" marL="0">
+              <a:lnSpc>
+                <a:spcPts val="940"/>
+              </a:lnSpc>
+              <a:buNone/>
+            </a:pPr>
+            <a:r>
+              <a:rPr lang="en-US" sz="720" b="1" dirty="0">
+                <a:solidFill>
+                  <a:srgbClr val="C6381A"/>
+                </a:solidFill>
+                <a:latin typeface="Avenir Next" pitchFamily="34" charset="0"/>
+                <a:ea typeface="Avenir Next" pitchFamily="34" charset="-122"/>
+                <a:cs typeface="Avenir Next" pitchFamily="34" charset="-120"/>
+              </a:rPr>
+              <a:t>D-68  </a:t>
+            </a:r>
+            <a:pPr indent="0" marL="0">
+              <a:lnSpc>
+                <a:spcPts val="940"/>
+              </a:lnSpc>
+              <a:buNone/>
+            </a:pPr>
+            <a:r>
+              <a:rPr lang="en-US" sz="720" dirty="0">
+                <a:solidFill>
+                  <a:srgbClr val="111111"/>
+                </a:solidFill>
+                <a:latin typeface="Avenir Next" pitchFamily="34" charset="0"/>
+                <a:ea typeface="Avenir Next" pitchFamily="34" charset="-122"/>
+                <a:cs typeface="Avenir Next" pitchFamily="34" charset="-120"/>
+              </a:rPr>
+              <a:t>First real page found a real extraction bug</a:t>
+            </a:r>
+            <a:endParaRPr lang="en-US" sz="720" dirty="0"/>
+          </a:p>
+          <a:p>
+            <a:pPr indent="0" marL="0">
+              <a:lnSpc>
+                <a:spcPts val="940"/>
+              </a:lnSpc>
+              <a:buNone/>
+            </a:pPr>
+            <a:r>
+              <a:rPr lang="en-US" sz="720" b="1" dirty="0">
+                <a:solidFill>
+                  <a:srgbClr val="C6381A"/>
+                </a:solidFill>
+                <a:latin typeface="Avenir Next" pitchFamily="34" charset="0"/>
+                <a:ea typeface="Avenir Next" pitchFamily="34" charset="-122"/>
+                <a:cs typeface="Avenir Next" pitchFamily="34" charset="-120"/>
+              </a:rPr>
+              <a:t>D-69  </a:t>
+            </a:r>
+            <a:pPr indent="0" marL="0">
+              <a:lnSpc>
+                <a:spcPts val="940"/>
+              </a:lnSpc>
+              <a:buNone/>
+            </a:pPr>
+            <a:r>
+              <a:rPr lang="en-US" sz="720" dirty="0">
+                <a:solidFill>
+                  <a:srgbClr val="111111"/>
+                </a:solidFill>
+                <a:latin typeface="Avenir Next" pitchFamily="34" charset="0"/>
+                <a:ea typeface="Avenir Next" pitchFamily="34" charset="-122"/>
+                <a:cs typeface="Avenir Next" pitchFamily="34" charset="-120"/>
+              </a:rPr>
+              <a:t>Unused fallback engine retired, not resynced</a:t>
+            </a:r>
+            <a:endParaRPr lang="en-US" sz="720" dirty="0"/>
+          </a:p>
+          <a:p>
+            <a:pPr indent="0" marL="0">
+              <a:lnSpc>
+                <a:spcPts val="940"/>
+              </a:lnSpc>
+              <a:buNone/>
+            </a:pPr>
+            <a:r>
+              <a:rPr lang="en-US" sz="720" b="1" dirty="0">
+                <a:solidFill>
+                  <a:srgbClr val="C6381A"/>
+                </a:solidFill>
+                <a:latin typeface="Avenir Next" pitchFamily="34" charset="0"/>
+                <a:ea typeface="Avenir Next" pitchFamily="34" charset="-122"/>
+                <a:cs typeface="Avenir Next" pitchFamily="34" charset="-120"/>
+              </a:rPr>
+              <a:t>D-71  </a:t>
+            </a:r>
+            <a:pPr indent="0" marL="0">
+              <a:lnSpc>
+                <a:spcPts val="940"/>
+              </a:lnSpc>
+              <a:buNone/>
+            </a:pPr>
+            <a:r>
+              <a:rPr lang="en-US" sz="720" dirty="0">
+                <a:solidFill>
+                  <a:srgbClr val="111111"/>
+                </a:solidFill>
+                <a:latin typeface="Avenir Next" pitchFamily="34" charset="0"/>
+                <a:ea typeface="Avenir Next" pitchFamily="34" charset="-122"/>
+                <a:cs typeface="Avenir Next" pitchFamily="34" charset="-120"/>
+              </a:rPr>
+              <a:t>A SQL comment that evaluates, found and fixed</a:t>
+            </a:r>
+            <a:endParaRPr lang="en-US" sz="720" dirty="0"/>
+          </a:p>
+          <a:p>
+            <a:pPr indent="0" marL="0">
+              <a:lnSpc>
+                <a:spcPts val="940"/>
+              </a:lnSpc>
+              <a:buNone/>
+            </a:pPr>
+            <a:r>
+              <a:rPr lang="en-US" sz="720" b="1" dirty="0">
+                <a:solidFill>
+                  <a:srgbClr val="C6381A"/>
+                </a:solidFill>
+                <a:latin typeface="Avenir Next" pitchFamily="34" charset="0"/>
+                <a:ea typeface="Avenir Next" pitchFamily="34" charset="-122"/>
+                <a:cs typeface="Avenir Next" pitchFamily="34" charset="-120"/>
+              </a:rPr>
+              <a:t>D-72  </a:t>
+            </a:r>
+            <a:pPr indent="0" marL="0">
+              <a:lnSpc>
+                <a:spcPts val="940"/>
+              </a:lnSpc>
+              <a:buNone/>
+            </a:pPr>
+            <a:r>
+              <a:rPr lang="en-US" sz="720" dirty="0">
+                <a:solidFill>
+                  <a:srgbClr val="111111"/>
+                </a:solidFill>
+                <a:latin typeface="Avenir Next" pitchFamily="34" charset="0"/>
+                <a:ea typeface="Avenir Next" pitchFamily="34" charset="-122"/>
+                <a:cs typeface="Avenir Next" pitchFamily="34" charset="-120"/>
+              </a:rPr>
+              <a:t>Corpus closed at 24 pages, not 50–100</a:t>
+            </a:r>
+            <a:endParaRPr lang="en-US" sz="720" dirty="0"/>
+          </a:p>
+          <a:p>
+            <a:pPr indent="0" marL="0">
+              <a:lnSpc>
+                <a:spcPts val="940"/>
+              </a:lnSpc>
+              <a:buNone/>
+            </a:pPr>
+            <a:r>
+              <a:rPr lang="en-US" sz="720" b="1" dirty="0">
+                <a:solidFill>
+                  <a:srgbClr val="C6381A"/>
+                </a:solidFill>
+                <a:latin typeface="Avenir Next" pitchFamily="34" charset="0"/>
+                <a:ea typeface="Avenir Next" pitchFamily="34" charset="-122"/>
+                <a:cs typeface="Avenir Next" pitchFamily="34" charset="-120"/>
+              </a:rPr>
+              <a:t>D-73  </a:t>
+            </a:r>
+            <a:pPr indent="0" marL="0">
+              <a:lnSpc>
+                <a:spcPts val="940"/>
+              </a:lnSpc>
+              <a:buNone/>
+            </a:pPr>
+            <a:r>
+              <a:rPr lang="en-US" sz="720" dirty="0">
+                <a:solidFill>
+                  <a:srgbClr val="111111"/>
+                </a:solidFill>
+                <a:latin typeface="Avenir Next" pitchFamily="34" charset="0"/>
+                <a:ea typeface="Avenir Next" pitchFamily="34" charset="-122"/>
+                <a:cs typeface="Avenir Next" pitchFamily="34" charset="-120"/>
+              </a:rPr>
+              <a:t>A correction that itself needed correcting</a:t>
+            </a:r>
+            <a:endParaRPr lang="en-US" sz="720" dirty="0"/>
+          </a:p>
+          <a:p>
+            <a:pPr indent="0" marL="0">
+              <a:lnSpc>
+                <a:spcPts val="940"/>
+              </a:lnSpc>
+              <a:buNone/>
+            </a:pPr>
+            <a:r>
+              <a:rPr lang="en-US" sz="720" b="1" dirty="0">
+                <a:solidFill>
+                  <a:srgbClr val="C6381A"/>
+                </a:solidFill>
+                <a:latin typeface="Avenir Next" pitchFamily="34" charset="0"/>
+                <a:ea typeface="Avenir Next" pitchFamily="34" charset="-122"/>
+                <a:cs typeface="Avenir Next" pitchFamily="34" charset="-120"/>
+              </a:rPr>
+              <a:t>D-01  </a:t>
+            </a:r>
+            <a:pPr indent="0" marL="0">
+              <a:lnSpc>
+                <a:spcPts val="940"/>
+              </a:lnSpc>
+              <a:buNone/>
+            </a:pPr>
+            <a:r>
+              <a:rPr lang="en-US" sz="720" dirty="0">
+                <a:solidFill>
+                  <a:srgbClr val="111111"/>
+                </a:solidFill>
+                <a:latin typeface="Avenir Next" pitchFamily="34" charset="0"/>
+                <a:ea typeface="Avenir Next" pitchFamily="34" charset="-122"/>
+                <a:cs typeface="Avenir Next" pitchFamily="34" charset="-120"/>
+              </a:rPr>
+              <a:t>Postgres over Sheets, from day one</a:t>
+            </a:r>
+            <a:endParaRPr lang="en-US" sz="720" dirty="0"/>
+          </a:p>
+          <a:p>
+            <a:pPr indent="0" marL="0">
+              <a:lnSpc>
+                <a:spcPts val="940"/>
+              </a:lnSpc>
+              <a:buNone/>
+            </a:pPr>
+            <a:r>
+              <a:rPr lang="en-US" sz="720" b="1" dirty="0">
+                <a:solidFill>
+                  <a:srgbClr val="C6381A"/>
+                </a:solidFill>
+                <a:latin typeface="Avenir Next" pitchFamily="34" charset="0"/>
+                <a:ea typeface="Avenir Next" pitchFamily="34" charset="-122"/>
+                <a:cs typeface="Avenir Next" pitchFamily="34" charset="-120"/>
+              </a:rPr>
+              <a:t>D-52  </a:t>
+            </a:r>
+            <a:pPr indent="0" marL="0">
+              <a:lnSpc>
+                <a:spcPts val="940"/>
+              </a:lnSpc>
+              <a:buNone/>
+            </a:pPr>
+            <a:r>
+              <a:rPr lang="en-US" sz="720" dirty="0">
+                <a:solidFill>
+                  <a:srgbClr val="111111"/>
+                </a:solidFill>
+                <a:latin typeface="Avenir Next" pitchFamily="34" charset="0"/>
+                <a:ea typeface="Avenir Next" pitchFamily="34" charset="-122"/>
+                <a:cs typeface="Avenir Next" pitchFamily="34" charset="-120"/>
+              </a:rPr>
+              <a:t>A golden-test harness pins the AI’s answer</a:t>
+            </a:r>
+            <a:endParaRPr lang="en-US" sz="720" dirty="0"/>
+          </a:p>
+          <a:p>
+            <a:pPr indent="0" marL="0">
+              <a:lnSpc>
+                <a:spcPts val="940"/>
+              </a:lnSpc>
+              <a:buNone/>
+            </a:pPr>
+            <a:r>
+              <a:rPr lang="en-US" sz="720" b="1" dirty="0">
+                <a:solidFill>
+                  <a:srgbClr val="C6381A"/>
+                </a:solidFill>
+                <a:latin typeface="Avenir Next" pitchFamily="34" charset="0"/>
+                <a:ea typeface="Avenir Next" pitchFamily="34" charset="-122"/>
+                <a:cs typeface="Avenir Next" pitchFamily="34" charset="-120"/>
+              </a:rPr>
+              <a:t>D-55  </a:t>
+            </a:r>
+            <a:pPr indent="0" marL="0">
+              <a:lnSpc>
+                <a:spcPts val="940"/>
+              </a:lnSpc>
+              <a:buNone/>
+            </a:pPr>
+            <a:r>
+              <a:rPr lang="en-US" sz="720" dirty="0">
+                <a:solidFill>
+                  <a:srgbClr val="111111"/>
+                </a:solidFill>
+                <a:latin typeface="Avenir Next" pitchFamily="34" charset="0"/>
+                <a:ea typeface="Avenir Next" pitchFamily="34" charset="-122"/>
+                <a:cs typeface="Avenir Next" pitchFamily="34" charset="-120"/>
+              </a:rPr>
+              <a:t>One shared validation subworkflow, not two</a:t>
+            </a:r>
+            <a:endParaRPr lang="en-US" sz="720" dirty="0"/>
+          </a:p>
+          <a:p>
+            <a:pPr indent="0" marL="0">
+              <a:lnSpc>
+                <a:spcPts val="940"/>
+              </a:lnSpc>
+              <a:buNone/>
+            </a:pPr>
+            <a:r>
+              <a:rPr lang="en-US" sz="720" b="1" dirty="0">
+                <a:solidFill>
+                  <a:srgbClr val="C6381A"/>
+                </a:solidFill>
+                <a:latin typeface="Avenir Next" pitchFamily="34" charset="0"/>
+                <a:ea typeface="Avenir Next" pitchFamily="34" charset="-122"/>
+                <a:cs typeface="Avenir Next" pitchFamily="34" charset="-120"/>
+              </a:rPr>
+              <a:t>D-61  </a:t>
+            </a:r>
+            <a:pPr indent="0" marL="0">
+              <a:lnSpc>
+                <a:spcPts val="940"/>
+              </a:lnSpc>
+              <a:buNone/>
+            </a:pPr>
+            <a:r>
+              <a:rPr lang="en-US" sz="720" dirty="0">
+                <a:solidFill>
+                  <a:srgbClr val="111111"/>
+                </a:solidFill>
+                <a:latin typeface="Avenir Next" pitchFamily="34" charset="0"/>
+                <a:ea typeface="Avenir Next" pitchFamily="34" charset="-122"/>
+                <a:cs typeface="Avenir Next" pitchFamily="34" charset="-120"/>
+              </a:rPr>
+              <a:t>An overclaim about a prior project, corrected twice</a:t>
+            </a:r>
+            <a:endParaRPr lang="en-US" sz="720" dirty="0"/>
+          </a:p>
+          <a:p>
+            <a:pPr indent="0" marL="0">
+              <a:lnSpc>
+                <a:spcPts val="940"/>
+              </a:lnSpc>
+              <a:buNone/>
+            </a:pPr>
+            <a:r>
+              <a:rPr lang="en-US" sz="720" i="1" dirty="0">
+                <a:solidFill>
+                  <a:srgbClr val="9A9A9A"/>
+                </a:solidFill>
+                <a:latin typeface="Avenir Next" pitchFamily="34" charset="0"/>
+                <a:ea typeface="Avenir Next" pitchFamily="34" charset="-122"/>
+                <a:cs typeface="Avenir Next" pitchFamily="34" charset="-120"/>
+              </a:rPr>
+              <a:t>…and 61 more</a:t>
+            </a:r>
+            <a:endParaRPr lang="en-US" sz="720" dirty="0"/>
+          </a:p>
+        </p:txBody>
+      </p:sp>
+      <p:sp>
+        <p:nvSpPr>
+          <p:cNvPr id="18" name="Text 16"/>
+          <p:cNvSpPr/>
+          <p:nvPr/>
+        </p:nvSpPr>
+        <p:spPr>
+          <a:xfrm>
+            <a:off x="566928" y="4334256"/>
+            <a:ext cx="8010144" cy="274320"/>
+          </a:xfrm>
+          <a:prstGeom prst="rect">
+            <a:avLst/>
+          </a:prstGeom>
+          <a:noFill/>
+          <a:ln/>
+        </p:spPr>
+        <p:txBody>
+          <a:bodyPr wrap="square" lIns="0" tIns="0" rIns="0" bIns="0" rtlCol="0" anchor="ctr"/>
+          <a:lstStyle/>
+          <a:p>
+            <a:pPr indent="0" marL="0">
+              <a:buNone/>
+            </a:pPr>
+            <a:r>
+              <a:rPr lang="en-US" sz="1100" b="1" dirty="0">
+                <a:solidFill>
+                  <a:srgbClr val="111111"/>
+                </a:solidFill>
+                <a:latin typeface="Avenir Next" pitchFamily="34" charset="0"/>
+                <a:ea typeface="Avenir Next" pitchFamily="34" charset="-122"/>
+                <a:cs typeface="Avenir Next" pitchFamily="34" charset="-120"/>
+              </a:rPr>
+              <a:t>Fixtures prove the logic. Real pages prove it survives markup nobody wrote for it.</a:t>
+            </a:r>
+            <a:endParaRPr lang="en-US" sz="1100" dirty="0"/>
+          </a:p>
+        </p:txBody>
+      </p:sp>
+    </p:spTree>
+  </p:cSld>
+  <p:clrMapOvr>
+    <a:masterClrMapping/>
+  </p:clrMapOvr>
+</p:sld>
+</file>
+
 <file path=ppt/slides/slide2.xml><?xml version="1.0" encoding="utf-8"?>
 <p:sld xmlns:a="http://schemas.openxmlformats.org/drawingml/2006/main" xmlns:r="http://schemas.openxmlformats.org/officeDocument/2006/relationships" xmlns:p="http://schemas.openxmlformats.org/presentationml/2006/main">
   <p:cSld name="Slide 2">
@@ -5178,7 +6413,7 @@
                 <a:ea typeface="Avenir Next" pitchFamily="34" charset="-122"/>
                 <a:cs typeface="Avenir Next" pitchFamily="34" charset="-120"/>
               </a:rPr>
-              <a:t>02 / 12</a:t>
+              <a:t>02 / 13</a:t>
             </a:r>
             <a:endParaRPr lang="en-US" sz="800" dirty="0"/>
           </a:p>
@@ -5666,7 +6901,7 @@
                 <a:ea typeface="Avenir Next" pitchFamily="34" charset="-122"/>
                 <a:cs typeface="Avenir Next" pitchFamily="34" charset="-120"/>
               </a:rPr>
-              <a:t>03 / 12</a:t>
+              <a:t>03 / 13</a:t>
             </a:r>
             <a:endParaRPr lang="en-US" sz="800" dirty="0"/>
           </a:p>
@@ -6257,7 +7492,7 @@
                 <a:ea typeface="Avenir Next" pitchFamily="34" charset="-122"/>
                 <a:cs typeface="Avenir Next" pitchFamily="34" charset="-120"/>
               </a:rPr>
-              <a:t>04 / 12</a:t>
+              <a:t>04 / 13</a:t>
             </a:r>
             <a:endParaRPr lang="en-US" sz="800" dirty="0"/>
           </a:p>
@@ -7236,7 +8471,7 @@
                 <a:ea typeface="Avenir Next" pitchFamily="34" charset="-122"/>
                 <a:cs typeface="Avenir Next" pitchFamily="34" charset="-120"/>
               </a:rPr>
-              <a:t>05 / 12</a:t>
+              <a:t>05 / 13</a:t>
             </a:r>
             <a:endParaRPr lang="en-US" sz="800" dirty="0"/>
           </a:p>
@@ -7466,7 +8701,7 @@
                 <a:ea typeface="Avenir Next" pitchFamily="34" charset="-122"/>
                 <a:cs typeface="Avenir Next" pitchFamily="34" charset="-120"/>
               </a:rPr>
-              <a:t>06 / 12</a:t>
+              <a:t>06 / 13</a:t>
             </a:r>
             <a:endParaRPr lang="en-US" sz="800" dirty="0"/>
           </a:p>
@@ -9057,7 +10292,7 @@
                 <a:ea typeface="Avenir Next" pitchFamily="34" charset="-122"/>
                 <a:cs typeface="Avenir Next" pitchFamily="34" charset="-120"/>
               </a:rPr>
-              <a:t>07 / 12</a:t>
+              <a:t>07 / 13</a:t>
             </a:r>
             <a:endParaRPr lang="en-US" sz="800" dirty="0"/>
           </a:p>
@@ -9407,7 +10642,7 @@
                 <a:ea typeface="Avenir Next" pitchFamily="34" charset="-122"/>
                 <a:cs typeface="Avenir Next" pitchFamily="34" charset="-120"/>
               </a:rPr>
-              <a:t>08 / 12</a:t>
+              <a:t>08 / 13</a:t>
             </a:r>
             <a:endParaRPr lang="en-US" sz="800" dirty="0"/>
           </a:p>
@@ -9814,7 +11049,7 @@
                 <a:ea typeface="Avenir Next" pitchFamily="34" charset="-122"/>
                 <a:cs typeface="Avenir Next" pitchFamily="34" charset="-120"/>
               </a:rPr>
-              <a:t>09 / 12</a:t>
+              <a:t>09 / 13</a:t>
             </a:r>
             <a:endParaRPr lang="en-US" sz="800" dirty="0"/>
           </a:p>

</xml_diff>

<commit_message>
D-74 addendum: deck's own decision-log entry count was one behind itself
Slide 12 stat panel and slide 13 footer still said '73 entries' because
they were authored before the D-74 log entry documenting them existed.
Corrected to 74. Every other number in the new/edited slides re-verified
against source (D-67 74.5%, D-72 24 pages, intake-form auth) and found
current.

Co-Authored-By: Claude Sonnet 5 <noreply@anthropic.com>
</commit_message>
<xml_diff>
--- a/A11yAudit_presentation.pptx
+++ b/A11yAudit_presentation.pptx
@@ -4233,7 +4233,7 @@
                 <a:ea typeface="Avenir Next" pitchFamily="34" charset="-122"/>
                 <a:cs typeface="Avenir Next" pitchFamily="34" charset="-120"/>
               </a:rPr>
-              <a:t>readme.md  ·  decision_log.md, 73 entries  ·  demo_output/  ·  screenshots/</a:t>
+              <a:t>readme.md  ·  decision_log.md, 74 entries  ·  demo_output/  ·  screenshots/</a:t>
             </a:r>
             <a:endParaRPr lang="en-US" sz="950" dirty="0"/>
           </a:p>
@@ -5704,7 +5704,7 @@
                 <a:ea typeface="Avenir Next" pitchFamily="34" charset="-122"/>
                 <a:cs typeface="Avenir Next" pitchFamily="34" charset="-120"/>
               </a:rPr>
-              <a:t>DECISION LOG: 73 ENTRIES</a:t>
+              <a:t>DECISION LOG: 74 ENTRIES</a:t>
             </a:r>
             <a:endParaRPr lang="en-US" sz="800" dirty="0"/>
           </a:p>

</xml_diff>

<commit_message>
pptx: sync entry count 74->75 (self-referential lag from D-75)
Same pattern as D-74's own addendum: the deck's decision-log stat panel
and footer were authored referencing 74 entries, then this session's own
review (D-75) added a 75th. Corrected in both places; '...and 61 more'
math re-verified (75 - 14 named = 61).

Co-Authored-By: Claude Sonnet 5 <noreply@anthropic.com>
</commit_message>
<xml_diff>
--- a/A11yAudit_presentation.pptx
+++ b/A11yAudit_presentation.pptx
@@ -4233,7 +4233,7 @@
                 <a:ea typeface="Avenir Next" pitchFamily="34" charset="-122"/>
                 <a:cs typeface="Avenir Next" pitchFamily="34" charset="-120"/>
               </a:rPr>
-              <a:t>readme.md  ·  decision_log.md, 74 entries  ·  demo_output/  ·  screenshots/</a:t>
+              <a:t>readme.md  ·  decision_log.md, 75 entries  ·  demo_output/  ·  screenshots/</a:t>
             </a:r>
             <a:endParaRPr lang="en-US" sz="950" dirty="0"/>
           </a:p>
@@ -5704,7 +5704,7 @@
                 <a:ea typeface="Avenir Next" pitchFamily="34" charset="-122"/>
                 <a:cs typeface="Avenir Next" pitchFamily="34" charset="-120"/>
               </a:rPr>
-              <a:t>DECISION LOG: 74 ENTRIES</a:t>
+              <a:t>DECISION LOG: 75 ENTRIES</a:t>
             </a:r>
             <a:endParaRPr lang="en-US" sz="800" dirty="0"/>
           </a:p>

</xml_diff>

<commit_message>
pptx: replace em-dash with hyphen in the two edited slides (11, 14)
Same mechanical punctuation swap as the markdown docs. The original
D-42 deck design never used em-dash at all; only the slides edited/added
this session (Limits, Iteration 2) had it.

Co-Authored-By: Claude Sonnet 5 <noreply@anthropic.com>
</commit_message>
<xml_diff>
--- a/A11yAudit_presentation.pptx
+++ b/A11yAudit_presentation.pptx
@@ -3821,7 +3821,7 @@
                 <a:ea typeface="Avenir Next" pitchFamily="34" charset="-122"/>
                 <a:cs typeface="Avenir Next" pitchFamily="34" charset="-120"/>
               </a:rPr>
-              <a:t>One rater hand-scored two fixtures blind and compared against the AI: 74.5% agreement. One rater, two fixtures — not PEMAT’s own two-rater design, and not a substitute for a false-positive rate from routine use.</a:t>
+              <a:t>One rater hand-scored two fixtures blind and compared against the AI: 74.5% agreement. One rater, two fixtures - not PEMAT’s own two-rater design, and not a substitute for a false-positive rate from routine use.</a:t>
             </a:r>
             <a:endParaRPr lang="en-US" sz="1050" dirty="0"/>
           </a:p>
@@ -5400,7 +5400,7 @@
                 <a:ea typeface="Avenir Next" pitchFamily="34" charset="-122"/>
                 <a:cs typeface="Avenir Next" pitchFamily="34" charset="-120"/>
               </a:rPr>
-              <a:t>The first live page submitted had its navigation and breadcrumbs read as article content — invisible on every fixture, since none had surrounding page chrome.</a:t>
+              <a:t>The first live page submitted had its navigation and breadcrumbs read as article content - invisible on every fixture, since none had surrounding page chrome.</a:t>
             </a:r>
             <a:endParaRPr lang="en-US" sz="900" dirty="0"/>
           </a:p>

</xml_diff>